<commit_message>
chore: corrige mensagem do commit
</commit_message>
<xml_diff>
--- a/BUG-001.pptx
+++ b/BUG-001.pptx
@@ -206,7 +206,7 @@
           <a:p>
             <a:fld id="{1AE07002-56FB-41C6-A6F7-CFD1D461F481}" type="datetimeFigureOut">
               <a:rPr lang="pt-BR" smtClean="0"/>
-              <a:t>10/10/2026</a:t>
+              <a:t>21/10/2026</a:t>
             </a:fld>
             <a:endParaRPr lang="pt-BR"/>
           </a:p>
@@ -1543,7 +1543,7 @@
           <a:p>
             <a:fld id="{74017B93-A402-4F37-AF24-558FA750DB0C}" type="datetimeFigureOut">
               <a:rPr lang="pt-BR" smtClean="0"/>
-              <a:t>10/10/2026</a:t>
+              <a:t>21/10/2026</a:t>
             </a:fld>
             <a:endParaRPr lang="pt-BR"/>
           </a:p>
@@ -1794,7 +1794,7 @@
           <a:p>
             <a:fld id="{74017B93-A402-4F37-AF24-558FA750DB0C}" type="datetimeFigureOut">
               <a:rPr lang="pt-BR" smtClean="0"/>
-              <a:t>10/10/2026</a:t>
+              <a:t>21/10/2026</a:t>
             </a:fld>
             <a:endParaRPr lang="pt-BR"/>
           </a:p>
@@ -2108,7 +2108,7 @@
           <a:p>
             <a:fld id="{74017B93-A402-4F37-AF24-558FA750DB0C}" type="datetimeFigureOut">
               <a:rPr lang="pt-BR" smtClean="0"/>
-              <a:t>10/10/2026</a:t>
+              <a:t>21/10/2026</a:t>
             </a:fld>
             <a:endParaRPr lang="pt-BR"/>
           </a:p>
@@ -2449,7 +2449,7 @@
           <a:p>
             <a:fld id="{74017B93-A402-4F37-AF24-558FA750DB0C}" type="datetimeFigureOut">
               <a:rPr lang="pt-BR" smtClean="0"/>
-              <a:t>10/10/2026</a:t>
+              <a:t>21/10/2026</a:t>
             </a:fld>
             <a:endParaRPr lang="pt-BR"/>
           </a:p>
@@ -2763,7 +2763,7 @@
           <a:p>
             <a:fld id="{74017B93-A402-4F37-AF24-558FA750DB0C}" type="datetimeFigureOut">
               <a:rPr lang="pt-BR" smtClean="0"/>
-              <a:t>10/10/2026</a:t>
+              <a:t>21/10/2026</a:t>
             </a:fld>
             <a:endParaRPr lang="pt-BR"/>
           </a:p>
@@ -3156,7 +3156,7 @@
           <a:p>
             <a:fld id="{74017B93-A402-4F37-AF24-558FA750DB0C}" type="datetimeFigureOut">
               <a:rPr lang="pt-BR" smtClean="0"/>
-              <a:t>10/10/2026</a:t>
+              <a:t>21/10/2026</a:t>
             </a:fld>
             <a:endParaRPr lang="pt-BR"/>
           </a:p>
@@ -3326,7 +3326,7 @@
           <a:p>
             <a:fld id="{74017B93-A402-4F37-AF24-558FA750DB0C}" type="datetimeFigureOut">
               <a:rPr lang="pt-BR" smtClean="0"/>
-              <a:t>10/10/2026</a:t>
+              <a:t>21/10/2026</a:t>
             </a:fld>
             <a:endParaRPr lang="pt-BR"/>
           </a:p>
@@ -3506,7 +3506,7 @@
           <a:p>
             <a:fld id="{74017B93-A402-4F37-AF24-558FA750DB0C}" type="datetimeFigureOut">
               <a:rPr lang="pt-BR" smtClean="0"/>
-              <a:t>10/10/2026</a:t>
+              <a:t>21/10/2026</a:t>
             </a:fld>
             <a:endParaRPr lang="pt-BR"/>
           </a:p>
@@ -3682,7 +3682,7 @@
           <a:p>
             <a:fld id="{74017B93-A402-4F37-AF24-558FA750DB0C}" type="datetimeFigureOut">
               <a:rPr lang="pt-BR" smtClean="0"/>
-              <a:t>10/10/2026</a:t>
+              <a:t>21/10/2026</a:t>
             </a:fld>
             <a:endParaRPr lang="pt-BR"/>
           </a:p>
@@ -3929,7 +3929,7 @@
           <a:p>
             <a:fld id="{74017B93-A402-4F37-AF24-558FA750DB0C}" type="datetimeFigureOut">
               <a:rPr lang="pt-BR" smtClean="0"/>
-              <a:t>10/10/2026</a:t>
+              <a:t>21/10/2026</a:t>
             </a:fld>
             <a:endParaRPr lang="pt-BR"/>
           </a:p>
@@ -4161,7 +4161,7 @@
           <a:p>
             <a:fld id="{74017B93-A402-4F37-AF24-558FA750DB0C}" type="datetimeFigureOut">
               <a:rPr lang="pt-BR" smtClean="0"/>
-              <a:t>10/10/2026</a:t>
+              <a:t>21/10/2026</a:t>
             </a:fld>
             <a:endParaRPr lang="pt-BR"/>
           </a:p>
@@ -4535,7 +4535,7 @@
           <a:p>
             <a:fld id="{74017B93-A402-4F37-AF24-558FA750DB0C}" type="datetimeFigureOut">
               <a:rPr lang="pt-BR" smtClean="0"/>
-              <a:t>10/10/2026</a:t>
+              <a:t>21/10/2026</a:t>
             </a:fld>
             <a:endParaRPr lang="pt-BR"/>
           </a:p>
@@ -4658,7 +4658,7 @@
           <a:p>
             <a:fld id="{74017B93-A402-4F37-AF24-558FA750DB0C}" type="datetimeFigureOut">
               <a:rPr lang="pt-BR" smtClean="0"/>
-              <a:t>10/10/2026</a:t>
+              <a:t>21/10/2026</a:t>
             </a:fld>
             <a:endParaRPr lang="pt-BR"/>
           </a:p>
@@ -4753,7 +4753,7 @@
           <a:p>
             <a:fld id="{74017B93-A402-4F37-AF24-558FA750DB0C}" type="datetimeFigureOut">
               <a:rPr lang="pt-BR" smtClean="0"/>
-              <a:t>10/10/2026</a:t>
+              <a:t>21/10/2026</a:t>
             </a:fld>
             <a:endParaRPr lang="pt-BR"/>
           </a:p>
@@ -5008,7 +5008,7 @@
           <a:p>
             <a:fld id="{74017B93-A402-4F37-AF24-558FA750DB0C}" type="datetimeFigureOut">
               <a:rPr lang="pt-BR" smtClean="0"/>
-              <a:t>10/10/2026</a:t>
+              <a:t>21/10/2026</a:t>
             </a:fld>
             <a:endParaRPr lang="pt-BR"/>
           </a:p>
@@ -5271,7 +5271,7 @@
           <a:p>
             <a:fld id="{74017B93-A402-4F37-AF24-558FA750DB0C}" type="datetimeFigureOut">
               <a:rPr lang="pt-BR" smtClean="0"/>
-              <a:t>10/10/2026</a:t>
+              <a:t>21/10/2026</a:t>
             </a:fld>
             <a:endParaRPr lang="pt-BR"/>
           </a:p>
@@ -6014,7 +6014,7 @@
           <a:p>
             <a:fld id="{74017B93-A402-4F37-AF24-558FA750DB0C}" type="datetimeFigureOut">
               <a:rPr lang="pt-BR" smtClean="0"/>
-              <a:t>10/10/2026</a:t>
+              <a:t>21/10/2026</a:t>
             </a:fld>
             <a:endParaRPr lang="pt-BR"/>
           </a:p>
@@ -7413,8 +7413,8 @@
         </p:blipFill>
         <p:spPr>
           <a:xfrm>
-            <a:off x="1716505" y="1690688"/>
-            <a:ext cx="8758989" cy="4926931"/>
+            <a:off x="2766958" y="1556414"/>
+            <a:ext cx="6658083" cy="3745172"/>
           </a:xfrm>
           <a:prstGeom prst="rect">
             <a:avLst/>

</xml_diff>